<commit_message>
fix(apple): la fila "hoy" de la slide 10, en la misma base que la de la parrilla
"Today's book €11.3M" era lo que tienda contrató de verdad en ago-sep
con su score interno (47,2% de la demanda), pero la fila se comparaba
con "Accepted by the grid 76,0% / €14.6M" mezclando bases: 76,0% es
demanda aceptada antes del take-up y 47,2% es contratado después.

Ahora las dos filas resumen van igual: porcentaje = demanda que pasa
la decisión (motor hoy 58,8%; parrilla 76,0%), producción = contratada
o esperada con la aceptación efectiva entre paréntesis (€11.3M (47,2%)
frente a €14.6M (61,2%)), riesgo 3,74% frente a 3,51%. Misma corrección
en la tabla del correo, con una frase que dice qué es la última fila.
El 58,8% sale de p0_demanda_por_estado (contratado + cancelado +
rechazado después). Ninguna cifra cambia.

Co-Authored-By: Claude Fable 5.1 <noreply@anthropic.com>
Claude-Session: https://claude.ai/code/session_01RrA1SUzLkXsHg8oJ4QFje3
</commit_message>
<xml_diff>
--- a/output/apple_deck/Apple_EFX_Study.pptx
+++ b/output/apple_deck/Apple_EFX_Study.pptx
@@ -4157,7 +4157,7 @@
                           </a:solidFill>
                           <a:latin typeface="Arial"/>
                         </a:rPr>
-                        <a:t>€14.6M</a:t>
+                        <a:t>€14.6M (61.2%)</a:t>
                       </a:r>
                     </a:p>
                   </a:txBody>
@@ -4281,53 +4281,53 @@
                           </a:solidFill>
                           <a:latin typeface="Arial"/>
                         </a:rPr>
-                        <a:t>Today's book, valued the same way</a:t>
-                      </a:r>
-                    </a:p>
-                  </a:txBody>
-                  <a:tcPr>
-                    <a:solidFill>
-                      <a:srgbClr val="FFFFFF"/>
-                    </a:solidFill>
-                  </a:tcPr>
-                </a:tc>
-                <a:tc>
-                  <a:txBody>
-                    <a:bodyPr/>
-                    <a:lstStyle/>
-                    <a:p>
-                      <a:pPr algn="r"/>
-                      <a:r>
-                        <a:rPr sz="1150" b="0">
-                          <a:solidFill>
-                            <a:srgbClr val="5D6D7E"/>
-                          </a:solidFill>
-                          <a:latin typeface="Arial"/>
-                        </a:rPr>
-                        <a:t>47.2%</a:t>
-                      </a:r>
-                    </a:p>
-                  </a:txBody>
-                  <a:tcPr>
-                    <a:solidFill>
-                      <a:srgbClr val="FFFFFF"/>
-                    </a:solidFill>
-                  </a:tcPr>
-                </a:tc>
-                <a:tc>
-                  <a:txBody>
-                    <a:bodyPr/>
-                    <a:lstStyle/>
-                    <a:p>
-                      <a:pPr algn="r"/>
-                      <a:r>
-                        <a:rPr sz="1150" b="0">
-                          <a:solidFill>
-                            <a:srgbClr val="5D6D7E"/>
-                          </a:solidFill>
-                          <a:latin typeface="Arial"/>
-                        </a:rPr>
-                        <a:t>€11.3M</a:t>
+                        <a:t>Engine today: approved → booked</a:t>
+                      </a:r>
+                    </a:p>
+                  </a:txBody>
+                  <a:tcPr>
+                    <a:solidFill>
+                      <a:srgbClr val="FFFFFF"/>
+                    </a:solidFill>
+                  </a:tcPr>
+                </a:tc>
+                <a:tc>
+                  <a:txBody>
+                    <a:bodyPr/>
+                    <a:lstStyle/>
+                    <a:p>
+                      <a:pPr algn="r"/>
+                      <a:r>
+                        <a:rPr sz="1150" b="0">
+                          <a:solidFill>
+                            <a:srgbClr val="5D6D7E"/>
+                          </a:solidFill>
+                          <a:latin typeface="Arial"/>
+                        </a:rPr>
+                        <a:t>58.8%</a:t>
+                      </a:r>
+                    </a:p>
+                  </a:txBody>
+                  <a:tcPr>
+                    <a:solidFill>
+                      <a:srgbClr val="FFFFFF"/>
+                    </a:solidFill>
+                  </a:tcPr>
+                </a:tc>
+                <a:tc>
+                  <a:txBody>
+                    <a:bodyPr/>
+                    <a:lstStyle/>
+                    <a:p>
+                      <a:pPr algn="r"/>
+                      <a:r>
+                        <a:rPr sz="1150" b="0">
+                          <a:solidFill>
+                            <a:srgbClr val="5D6D7E"/>
+                          </a:solidFill>
+                          <a:latin typeface="Arial"/>
+                        </a:rPr>
+                        <a:t>€11.3M (47.2%)</a:t>
                       </a:r>
                     </a:p>
                   </a:txBody>

</xml_diff>

<commit_message>
fix(apple): la fila "hoy" de la slide 10, en la misma base que la de la parrilla (#253)
"Today's book €11.3M" era lo que tienda contrató de verdad en ago-sep
con su score interno (47,2% de la demanda), pero la fila se comparaba
con "Accepted by the grid 76,0% / €14.6M" mezclando bases: 76,0% es
demanda aceptada antes del take-up y 47,2% es contratado después.

Ahora las dos filas resumen van igual: porcentaje = demanda que pasa
la decisión (motor hoy 58,8%; parrilla 76,0%), producción = contratada
o esperada con la aceptación efectiva entre paréntesis (€11.3M (47,2%)
frente a €14.6M (61,2%)), riesgo 3,74% frente a 3,51%. Misma corrección
en la tabla del correo, con una frase que dice qué es la última fila.
El 58,8% sale de p0_demanda_por_estado (contratado + cancelado +
rechazado después). Ninguna cifra cambia.


Claude-Session: https://claude.ai/code/session_01RrA1SUzLkXsHg8oJ4QFje3

Co-authored-by: Claude Fable 5.1 <noreply@anthropic.com>
</commit_message>
<xml_diff>
--- a/output/apple_deck/Apple_EFX_Study.pptx
+++ b/output/apple_deck/Apple_EFX_Study.pptx
@@ -4157,7 +4157,7 @@
                           </a:solidFill>
                           <a:latin typeface="Arial"/>
                         </a:rPr>
-                        <a:t>€14.6M</a:t>
+                        <a:t>€14.6M (61.2%)</a:t>
                       </a:r>
                     </a:p>
                   </a:txBody>
@@ -4281,53 +4281,53 @@
                           </a:solidFill>
                           <a:latin typeface="Arial"/>
                         </a:rPr>
-                        <a:t>Today's book, valued the same way</a:t>
-                      </a:r>
-                    </a:p>
-                  </a:txBody>
-                  <a:tcPr>
-                    <a:solidFill>
-                      <a:srgbClr val="FFFFFF"/>
-                    </a:solidFill>
-                  </a:tcPr>
-                </a:tc>
-                <a:tc>
-                  <a:txBody>
-                    <a:bodyPr/>
-                    <a:lstStyle/>
-                    <a:p>
-                      <a:pPr algn="r"/>
-                      <a:r>
-                        <a:rPr sz="1150" b="0">
-                          <a:solidFill>
-                            <a:srgbClr val="5D6D7E"/>
-                          </a:solidFill>
-                          <a:latin typeface="Arial"/>
-                        </a:rPr>
-                        <a:t>47.2%</a:t>
-                      </a:r>
-                    </a:p>
-                  </a:txBody>
-                  <a:tcPr>
-                    <a:solidFill>
-                      <a:srgbClr val="FFFFFF"/>
-                    </a:solidFill>
-                  </a:tcPr>
-                </a:tc>
-                <a:tc>
-                  <a:txBody>
-                    <a:bodyPr/>
-                    <a:lstStyle/>
-                    <a:p>
-                      <a:pPr algn="r"/>
-                      <a:r>
-                        <a:rPr sz="1150" b="0">
-                          <a:solidFill>
-                            <a:srgbClr val="5D6D7E"/>
-                          </a:solidFill>
-                          <a:latin typeface="Arial"/>
-                        </a:rPr>
-                        <a:t>€11.3M</a:t>
+                        <a:t>Engine today: approved → booked</a:t>
+                      </a:r>
+                    </a:p>
+                  </a:txBody>
+                  <a:tcPr>
+                    <a:solidFill>
+                      <a:srgbClr val="FFFFFF"/>
+                    </a:solidFill>
+                  </a:tcPr>
+                </a:tc>
+                <a:tc>
+                  <a:txBody>
+                    <a:bodyPr/>
+                    <a:lstStyle/>
+                    <a:p>
+                      <a:pPr algn="r"/>
+                      <a:r>
+                        <a:rPr sz="1150" b="0">
+                          <a:solidFill>
+                            <a:srgbClr val="5D6D7E"/>
+                          </a:solidFill>
+                          <a:latin typeface="Arial"/>
+                        </a:rPr>
+                        <a:t>58.8%</a:t>
+                      </a:r>
+                    </a:p>
+                  </a:txBody>
+                  <a:tcPr>
+                    <a:solidFill>
+                      <a:srgbClr val="FFFFFF"/>
+                    </a:solidFill>
+                  </a:tcPr>
+                </a:tc>
+                <a:tc>
+                  <a:txBody>
+                    <a:bodyPr/>
+                    <a:lstStyle/>
+                    <a:p>
+                      <a:pPr algn="r"/>
+                      <a:r>
+                        <a:rPr sz="1150" b="0">
+                          <a:solidFill>
+                            <a:srgbClr val="5D6D7E"/>
+                          </a:solidFill>
+                          <a:latin typeface="Arial"/>
+                        </a:rPr>
+                        <a:t>€11.3M (47.2%)</a:t>
                       </a:r>
                     </a:p>
                   </a:txBody>

</xml_diff>